<commit_message>
DP1 decision-locus deck: add presentation scripts to slide notes (structure comparison, 보완 설계)
Co-Authored-By: Claude Sonnet 5.5 <noreply@anthropic.com>
Claude-Session: https://claude.ai/code/session_016UbR8g5yrMQeToMMb2Hem6
</commit_message>
<xml_diff>
--- a/doc-mk/slides/dp1-decision-locus-candidates.pptx
+++ b/doc-mk/slides/dp1-decision-locus-candidates.pptx
@@ -507,6 +507,68 @@
           <a:lstStyle/>
           <a:p>
             <a:r>
+              <a:t>[발표 스크립트 · 약 3분]</a:t>
+            </a:r>
+          </a:p>
+          <a:p>
+            <a:r>
+              <a:t>이 장은 DP1, 즉 이동 결정 기능을 어디에 둘 것인가를 두 가지 구조로 비교합니다.</a:t>
+            </a:r>
+          </a:p>
+          <a:p/>
+          <a:p>
+            <a:r>
+              <a:t>먼저 공통점부터 말씀드리겠습니다. 두 안은 같은 모듈을 씁니다. 결정은 Trend Analyzer, Affinity Mapper, Policy Engine이 맡고, 상태는 State Monitor, Telemetry Collector, Registry가, 실행은 Migration Executor와 Transfer Handler가 맡습니다. 노란색이 결정 로직 모듈인데, 두 안은 이 세 모듈이 어디에 있느냐만 다릅니다. 자원 상태를 볼지 data 행동을 볼지 같은 신호 종류는 정책 플러그인으로 내려서 두 안에 공통으로 두었습니다. 즉 이 비교는 정책 비교가 아니라 구조 비교입니다.</a:t>
+            </a:r>
+          </a:p>
+          <a:p/>
+          <a:p>
+            <a:r>
+              <a:t>왼쪽 1안은 결정 로직을 상태를 가진 Resource Manager 안에 둡니다. Control은 Scheduler로 평가 시점과 budget만 정합니다. 흐름은 ①Scheduler가 평가 cycle을 시작하면, ②Resource Manager 안에서 상태를 로컬 호출로 읽고, ③Analyzer, Mapper, Policy Engine 순으로 판단해서, ④MigrationIntent를 Data Plane의 Executor로 보냅니다. ⑥이동이 실행되고, ⑤commit 결과가 Registry에 반영됩니다. 장점은 조회 hop이 없고 상태 변화가 바로 반영된다는 점입니다. 단점은 정책을 바꾸면 상태 서비스를 같이 수정해야 하고, 상태 저장과 판단이 한 서비스에 묶여 있어서 tier나 object가 늘면 단일 병목이 될 수 있다는 점입니다.</a:t>
+            </a:r>
+          </a:p>
+          <a:p/>
+          <a:p>
+            <a:r>
+              <a:t>오른쪽 2안은 결정 로직을 Control에 두고 Resource Manager는 상태와 관측만 맡습니다. 같은 흐름에서 ②번이 snapshot query로 바뀝니다. 장점은 정책 교체와 추가가 Control 안에서 끝나서 상태 서비스는 건드리지 않는다는 점, 판단과 상태를 따로 확장할 수 있다는 점입니다. Q1 관점의 장점도 있습니다. 판단 부하와 상태 갱신 경로가 분리되어 있어서, 판단이 길어져도 commit 반영과 수집이 막히지 않고, 판단 스레드를 서빙 코어와 분리해서 배치할 수 있습니다. 단점은 snapshot 조회 hop이 하나 늘고 snapshot age만큼 상태가 stale할 수 있다는 점, 그리고 query 스키마를 설계하고 유지해야 한다는 점입니다.</a:t>
+            </a:r>
+          </a:p>
+          <a:p/>
+          <a:p>
+            <a:r>
+              <a:t>한 가지 짚겠습니다. 결정은 event 기반 비동기라 forward critical path 밖에 있으므로 Q1 차이는 크지 않을 수 있습니다. 표의 우열은 모두 평가 전 가설이고, 별점은 임계값 통합 후에 부여합니다. 같은 정책을 두 구조에 올려서 결정 경로 hop, 수정 모듈 수, 지연 증가율로 비교할 계획입니다.</a:t>
+            </a:r>
+          </a:p>
+          <a:p/>
+          <a:p>
+            <a:r>
+              <a:t>정리하면 바뀌는 변수는 하나, 결정 로직의 소속입니다. 상태 가까이 두면 지연이 짧고 단순하며, 분리하면 변경과 확장에 유리합니다.</a:t>
+            </a:r>
+          </a:p>
+          <a:p/>
+          <a:p>
+            <a:r>
+              <a:t>예상 질문</a:t>
+            </a:r>
+          </a:p>
+          <a:p>
+            <a:r>
+              <a:t>- 결국 정책 차이 아닌가요? → 신호는 정책 플러그인으로 공통이고, 두 안은 모듈 소속과 호출 경계가 다릅니다. 같은 정책을 올려 비교합니다.</a:t>
+            </a:r>
+          </a:p>
+          <a:p>
+            <a:r>
+              <a:t>- 1안의 Resource Manager 이름이 맞나요? → 상태 소유자가 판단까지 하는 co-location 안이라 (상태 + 결정)으로 표기했습니다. 이 결합이 곧 비교 변수입니다.</a:t>
+            </a:r>
+          </a:p>
+          <a:p/>
+          <a:p>
+            <a:r>
+              <a:t>[핵심 · 근거 · 선택의 의미]</a:t>
+            </a:r>
+          </a:p>
+          <a:p>
+            <a:r>
               <a:t>핵심: 두 안은 같은 모듈 집합을 쓰고, 결정 로직(Analyzer, Mapper, Policy Engine)의 소속만 다르다. 1안은 상태 소유자인 Resource Manager 안에, 2안은 Control에 둔다.</a:t>
             </a:r>
           </a:p>
@@ -750,6 +812,74 @@
         <p:txBody>
           <a:bodyPr/>
           <a:lstStyle/>
+          <a:p>
+            <a:r>
+              <a:t>[발표 스크립트 · 약 2분 30초]</a:t>
+            </a:r>
+          </a:p>
+          <a:p>
+            <a:r>
+              <a:t>이 장은 선택한 안, 즉 AI Data 특성에 우선한 이동에 보완 설계를 적용한 구조입니다. 왼쪽 흐린 그림은 기존 설계를 결정 위치 구조로 다시 그린 것으로, 판단은 Control, 상태와 관측은 Resource Manager가 맡습니다. 오른쪽이 보완한 구조입니다.</a:t>
+            </a:r>
+          </a:p>
+          <a:p/>
+          <a:p>
+            <a:r>
+              <a:t>기존 설계의 단점은 두 가지였습니다. 첫째, behavior 예측이 틀리면 idle data가 HBM을 불필요하게 점유합니다(Q2). 둘째, 신규 workload가 추가되면 변경 영향 범위가 큽니다(Q3).</a:t>
+            </a:r>
+          </a:p>
+          <a:p/>
+          <a:p>
+            <a:r>
+              <a:t>첫 번째 보완은 HBM 점유 기한, 즉 Lease입니다. 데이터를 HBM에 올릴 때 Policy Engine 안의 HBM Lease Granter가 Lease를 부여하고, 만료 시각은 Data Object Registry의 Lease Metadata에 기록합니다. ⑦번 흐름입니다. 기한이 지나면 Lease Timer가 Lease Expired event를 Scheduler로 보냅니다. ⑧번 흐름입니다. 그러면 평가 cycle이 다시 돌고, 최신 behavior를 보고 Lease를 연장하거나 demotion합니다. 그래서 idle data가 HBM을 점유하는 기간에 상한이 생깁니다.</a:t>
+            </a:r>
+          </a:p>
+          <a:p/>
+          <a:p>
+            <a:r>
+              <a:t>여기서 배치 원칙을 말씀드립니다. 판단인 Granter는 Control에 두고, Lease Timer는 Resource Manager에 둡니다. 만료 시각은 상태이므로 상태를 가진 쪽이 event를 발생시키고, Control이 Registry를 계속 조회할 필요가 없게 했습니다. 판단은 Control, 상태와 event 원천은 Resource Manager라는 앞 장의 원칙을 그대로 적용한 것입니다.</a:t>
+            </a:r>
+          </a:p>
+          <a:p/>
+          <a:p>
+            <a:r>
+              <a:t>두 번째 보완은 Behavior Feature Adapter입니다. Resource Manager의 조회 경계에서 workload별 raw behavior를 공통 Feature snapshot으로 바꿔서 ②번으로 넘깁니다. Control의 Analyzer와 Policy Engine은 workload 종류를 몰라도 되므로, 신규 workload는 Adapter 하나만 추가하면 됩니다. 이 Adapter는 부수 효과도 있습니다. 2안 구조의 약점이었던 query 스키마 유지 비용이 줄어듭니다. 스키마가 workload와 무관하게 고정되기 때문입니다.</a:t>
+            </a:r>
+          </a:p>
+          <a:p/>
+          <a:p>
+            <a:r>
+              <a:t>Tradeoff입니다. Q1은 Lease 갱신이 판단 경로와 분리되어 유지될 것으로 봅니다. Q2는 idle data 점유에 만료 상한이 생겨 개선, Q3은 workload 추가가 Adapter 1개로 줄어 개선입니다. Q4는 확인이 필요합니다. Lease 수가 object 수에 비례하므로 timer 관리 비용이 늘 수 있습니다. 모두 가설이고 별점은 구조 변경 후 재평가하겠습니다.</a:t>
+            </a:r>
+          </a:p>
+          <a:p/>
+          <a:p>
+            <a:r>
+              <a:t>감수한 불이익과 미설계 사항을 말씀드립니다. Lease 만료가 한꺼번에 몰릴 때의 처리는 아직 설계하지 않았습니다. 만료 시각 분산이나 배치 처리를 검토해야 합니다. Lease 기한을 얼마로 할지는 정책 파라미터라서 이 장에서는 구조만 다루고, sweep으로 확인할 예정입니다.</a:t>
+            </a:r>
+          </a:p>
+          <a:p/>
+          <a:p>
+            <a:r>
+              <a:t>예상 질문</a:t>
+            </a:r>
+          </a:p>
+          <a:p>
+            <a:r>
+              <a:t>- Lease Timer를 왜 Resource Manager에 두었나요? → 만료 시각이 상태이기 때문입니다. event 원천을 상태 소유 측에 두면 Control의 폴링이 필요 없습니다. 원안처럼 Control에 두는 대안도 있고, 그 경우 폴링이 생깁니다.</a:t>
+            </a:r>
+          </a:p>
+          <a:p>
+            <a:r>
+              <a:t>- Adapter를 Control에 두면 안 되나요? → 가능하지만 그러면 Control이 workload별 raw 형식을 알게 되어 변경 범위가 다시 커집니다.</a:t>
+            </a:r>
+          </a:p>
+          <a:p/>
+          <a:p>
+            <a:r>
+              <a:t>[핵심 · 근거 · 선택의 의미]</a:t>
+            </a:r>
+          </a:p>
           <a:p>
             <a:r>
               <a:t>핵심: 원안 2안의 보완(Lease, Behavior adapter)을 결정 위치 구조(판단은 Control, 상태는 Resource Manager)에 맞춰 배치했다.</a:t>

</xml_diff>

<commit_message>
DP1 decision-locus deck: rework Q1 basis (drop hop metric and 'async so small' claim)
Q1 is the primary QA. Replace the hop-based Q1 argument with indirect paths
(HBM headroom latency, state-update contention, stale-decision rejects) and
mark the Lease supplement's Q1 as needing verification.

Co-Authored-By: Claude Sonnet 5.5 <noreply@anthropic.com>
Claude-Session: https://claude.ai/code/session_016UbR8g5yrMQeToMMb2Hem6
</commit_message>
<xml_diff>
--- a/doc-mk/slides/dp1-decision-locus-candidates.pptx
+++ b/doc-mk/slides/dp1-decision-locus-candidates.pptx
@@ -524,19 +524,19 @@
           <a:p/>
           <a:p>
             <a:r>
-              <a:t>왼쪽 1안은 결정 로직을 상태를 가진 Resource Manager 안에 둡니다. Control은 Scheduler로 평가 시점과 budget만 정합니다. 흐름은 ①Scheduler가 평가 cycle을 시작하면, ②Resource Manager 안에서 상태를 로컬 호출로 읽고, ③Analyzer, Mapper, Policy Engine 순으로 판단해서, ④MigrationIntent를 Data Plane의 Executor로 보냅니다. ⑥이동이 실행되고, ⑤commit 결과가 Registry에 반영됩니다. 장점은 조회 hop이 없고 상태 변화가 바로 반영된다는 점입니다. 단점은 정책을 바꾸면 상태 서비스를 같이 수정해야 하고, 상태 저장과 판단이 한 서비스에 묶여 있어서 tier나 object가 늘면 단일 병목이 될 수 있다는 점입니다.</a:t>
+              <a:t>왼쪽 1안은 결정 로직을 상태를 가진 Resource Manager 안에 둡니다. Control은 Scheduler로 평가 시점과 budget만 정합니다. 흐름은 ①Scheduler가 평가 cycle을 시작하면, ②Resource Manager 안에서 상태를 로컬 호출로 읽고, ③Analyzer, Mapper, Policy Engine 순으로 판단해서, ④MigrationIntent를 Data Plane의 Executor로 보냅니다. ⑥이동이 실행되고, ⑤commit 결과가 Registry에 반영됩니다. 장점은 상태가 항상 최신이라 HBM 압박에 대한 대응이 가장 빠르다는 점입니다. 단점은 정책을 바꾸면 상태 서비스를 같이 수정해야 하고, 상태 저장과 판단이 한 서비스에 묶여 있어서 판단이 길어지는 동안 상태 갱신과 수집이 막힐 수 있다는 점, 그리고 tier나 object가 늘면 단일 병목이 될 수 있다는 점입니다.</a:t>
             </a:r>
           </a:p>
           <a:p/>
           <a:p>
             <a:r>
-              <a:t>오른쪽 2안은 결정 로직을 Control에 두고 Resource Manager는 상태와 관측만 맡습니다. 같은 흐름에서 ②번이 snapshot query로 바뀝니다. 장점은 정책 교체와 추가가 Control 안에서 끝나서 상태 서비스는 건드리지 않는다는 점, 판단과 상태를 따로 확장할 수 있다는 점입니다. Q1 관점의 장점도 있습니다. 판단 부하와 상태 갱신 경로가 분리되어 있어서, 판단이 길어져도 commit 반영과 수집이 막히지 않고, 판단 스레드를 서빙 코어와 분리해서 배치할 수 있습니다. 단점은 snapshot 조회 hop이 하나 늘고 snapshot age만큼 상태가 stale할 수 있다는 점, 그리고 query 스키마를 설계하고 유지해야 한다는 점입니다.</a:t>
+              <a:t>오른쪽 2안은 결정 로직을 Control에 두고 Resource Manager는 상태와 관측만 맡습니다. 같은 흐름에서 ②번이 snapshot query로 바뀝니다. 장점은 정책 교체와 추가가 Control 안에서 끝나서 상태 서비스는 건드리지 않는다는 점, 판단과 상태를 따로 확장할 수 있다는 점입니다. Q1 관점의 장점도 있습니다. 판단이 snapshot 위에서 돌아서 상태 갱신·수집 경로와 경합하지 않으므로, 판단이 길어져도 commit 반영과 event 수집이 막히지 않고, 판단 스레드를 서빙 코어와 분리해서 배치할 수 있습니다. 단점은 snapshot age만큼 상태가 stale해서 HBM 확보가 늦어지거나, 오래된 정보로 판단한 이동이 거절되어 재시도될 수 있다는 점, 그리고 snapshot 생성 비용과 query 스키마 유지 비용이 든다는 점입니다.</a:t>
             </a:r>
           </a:p>
           <a:p/>
           <a:p>
             <a:r>
-              <a:t>한 가지 짚겠습니다. 결정은 event 기반 비동기라 forward critical path 밖에 있으므로 Q1 차이는 크지 않을 수 있습니다. 표의 우열은 모두 평가 전 가설이고, 별점은 임계값 통합 후에 부여합니다. 같은 정책을 두 구조에 올려서 결정 경로 hop, 수정 모듈 수, 지연 증가율로 비교할 계획입니다.</a:t>
+              <a:t>가장 중요한 QA인 Q1이 어디서 갈리는지 분명히 말씀드립니다. 결정 호출이 비동기여도 Q1에는 간접 경로가 남습니다. HBM 확보가 늦으면 신규 요청이 대기하거나 preemption으로 재계산이 생기고, 판단이 상태 갱신을 막으면 event가 밀리며, 오래된 정보로 내린 이동은 거절되어 링크를 낭비합니다. 1안은 최신 상태가 강점이고 경합이 약점이며, 2안은 경합 격리가 강점이고 stale이 약점입니다. 표의 우열은 모두 평가 전 가설이고 별점은 임계값 통합 후에 부여합니다. 같은 정책을 두 구조에 올려 snapshot age, 판단 비용, 상태 갱신 rate를 바꿔 가며 Max SLO Goodput과 분해 지표(HBM 확보 지연, 이동 거절율, TPOT P99)로 비교할 계획입니다.</a:t>
             </a:r>
           </a:p>
           <a:p/>
@@ -574,7 +574,7 @@
           </a:p>
           <a:p>
             <a:r>
-              <a:t>근거: 소속이 바뀌면 호출 경계가 바뀐다(로컬 호출 vs snapshot query). 그 결과 결정 경로 hop, 상태 stale, 정책 변경 시 수정 모듈, 서비스 확장 단위가 달라진다.</a:t>
+              <a:t>근거: 소속이 바뀌면 호출 경계가 바뀐다(로컬 호출 vs snapshot query). 그 결과 상태 stale, 상태 갱신과 판단 간 경합, 정책 변경 시 수정 모듈, 서비스 확장 단위가 달라진다.</a:t>
             </a:r>
           </a:p>
           <a:p>
@@ -739,12 +739,12 @@
           </a:p>
           <a:p>
             <a:r>
-              <a:t>근거: Q1은 결정 경로 hop, Q2는 stale window, Q3은 정책 변경 시 수정 모듈 수, Q4는 N 증가 시 지연 증가율로 환산한다. 숫자는 아직 없고 모두 가설·추정이다.</a:t>
-            </a:r>
-          </a:p>
-          <a:p>
-            <a:r>
-              <a:t>선택의 의미: Q1은 결정이 비동기라 차이가 작을 수 있어 Q2~Q4가 변별력의 중심이다. 시뮬레이션 [B+C] 전에는 우열을 단정하지 않는다.</a:t>
+              <a:t>근거: Q1은 Max SLO Goodput과 그 분해(HBM 확보 지연, 상태 갱신 지연, 이동 거절율), Q2는 stale window, Q3은 정책 변경 시 수정 모듈 수, Q4는 N 증가 시 지연 증가율로 환산한다. 숫자는 아직 없고 모두 가설·추정이다.</a:t>
+            </a:r>
+          </a:p>
+          <a:p>
+            <a:r>
+              <a:t>선택의 의미: 호출이 비동기여도 Q1에는 간접 경로(확보 지연, event 지연, 링크 낭비)가 있어, 1안(최신 상태 vs 경합)과 2안(경합 격리 vs stale)이 서로 반대 방향으로 갈린다. 가장 중요한 QA이므로 시뮬레이션 [B+C]로 먼저 확인한다.</a:t>
             </a:r>
           </a:p>
         </p:txBody>
@@ -849,7 +849,7 @@
           <a:p/>
           <a:p>
             <a:r>
-              <a:t>Tradeoff입니다. Q1은 Lease 갱신이 판단 경로와 분리되어 유지될 것으로 봅니다. Q2는 idle data 점유에 만료 상한이 생겨 개선, Q3은 workload 추가가 Adapter 1개로 줄어 개선입니다. Q4는 확인이 필요합니다. Lease 수가 object 수에 비례하므로 timer 관리 비용이 늘 수 있습니다. 모두 가설이고 별점은 구조 변경 후 재평가하겠습니다.</a:t>
+              <a:t>Tradeoff입니다. Q1은 확인이 필요합니다. Lease 갱신 자체는 판단 경로와 분리되어 부담이 작지만, 만료 시 오판으로 곧 쓸 데이터를 내리면 다시 올리는 비용이 생겨 처리량이 떨어질 수 있습니다. 연장 규칙이 관건입니다. Q2는 idle data 점유에 만료 상한이 생겨 개선, Q3은 workload 추가가 Adapter 1개로 줄어 개선입니다. Q4는 확인이 필요합니다. Lease 수가 object 수에 비례하므로 timer 관리 비용이 늘 수 있습니다. 모두 가설이고 별점은 구조 변경 후 재평가하겠습니다.</a:t>
             </a:r>
           </a:p>
           <a:p/>
@@ -5310,7 +5310,7 @@
         </p:nvGraphicFramePr>
         <p:xfrm>
           <a:off x="246888" y="1042415"/>
-          <a:ext cx="11740896" cy="5193792"/>
+          <a:ext cx="11740896" cy="5166360"/>
         </p:xfrm>
         <a:graphic>
           <a:graphicData uri="http://schemas.openxmlformats.org/drawingml/2006/table">
@@ -5679,7 +5679,7 @@
                   </a:tcPr>
                 </a:tc>
               </a:tr>
-              <a:tr h="786384">
+              <a:tr h="749808">
                 <a:tc>
                   <a:txBody>
                     <a:bodyPr wrap="square"/>
@@ -5748,7 +5748,7 @@
                           <a:ea typeface="맑은 고딕"/>
                           <a:cs typeface="맑은 고딕"/>
                         </a:rPr>
-                        <a:t>• 상태 조회가 로컬 호출 → snapshot 복사·hop 없음, 상태 변화에 즉시 반영 (Q1·Q2)</a:t>
+                        <a:t>• 상태가 항상 최신 → HBM 압박 대응 지연 최소, 오래된 정보로 인한 이동 거절 없음 (Q1·Q2)</a:t>
                       </a:r>
                     </a:p>
                     <a:p>
@@ -5815,7 +5815,7 @@
                           <a:ea typeface="맑은 고딕"/>
                           <a:cs typeface="맑은 고딕"/>
                         </a:rPr>
-                        <a:t>• 판단 부하와 상태 갱신·수집 경로가 분리 → 판단이 길어도 commit 반영이 막히지 않고, 판단 스레드를 서빙 코어와 분리 배치 가능 (Q1)</a:t>
+                        <a:t>• 판단이 snapshot 위에서 돌아 상태 갱신·수집과 경합 없음 → event backlog·TPOT 간섭 격리, 판단 스레드를 서빙 코어와 분리 배치 가능 (Q1)</a:t>
                       </a:r>
                     </a:p>
                     <a:p>
@@ -5882,7 +5882,7 @@
                   </a:tcPr>
                 </a:tc>
               </a:tr>
-              <a:tr h="502920">
+              <a:tr h="548640">
                 <a:tc>
                   <a:txBody>
                     <a:bodyPr wrap="square"/>
@@ -5969,7 +5969,7 @@
                           <a:ea typeface="맑은 고딕"/>
                           <a:cs typeface="맑은 고딕"/>
                         </a:rPr>
-                        <a:t>• 상태 저장과 판단이 한 서비스에 결합 → tier·object 수 증가 시 단일 병목 (Q4)</a:t>
+                        <a:t>• 상태 저장과 판단이 한 서비스에 결합 → 판단 중 상태 갱신이 막혀 event 지연 (Q1), tier·object 증가 시 단일 병목 (Q4)</a:t>
                       </a:r>
                     </a:p>
                   </a:txBody>
@@ -6018,7 +6018,7 @@
                           <a:ea typeface="맑은 고딕"/>
                           <a:cs typeface="맑은 고딕"/>
                         </a:rPr>
-                        <a:t>• snapshot 조회 hop과 snapshot age만큼 stale (Q1·Q2)</a:t>
+                        <a:t>• snapshot age만큼 stale → HBM 확보 지연, stale 판단의 이동 거절·재시도 (Q1·Q2)</a:t>
                       </a:r>
                     </a:p>
                     <a:p>
@@ -6036,7 +6036,7 @@
                           <a:ea typeface="맑은 고딕"/>
                           <a:cs typeface="맑은 고딕"/>
                         </a:rPr>
-                        <a:t>• query 스키마(인터페이스) 설계·유지 비용</a:t>
+                        <a:t>• snapshot 생성 비용(object 수 비례), query 스키마 유지 비용</a:t>
                       </a:r>
                     </a:p>
                   </a:txBody>
@@ -6067,7 +6067,7 @@
                   </a:tcPr>
                 </a:tc>
               </a:tr>
-              <a:tr h="566928">
+              <a:tr h="530352">
                 <a:tc>
                   <a:txBody>
                     <a:bodyPr wrap="square"/>
@@ -6136,7 +6136,7 @@
                           <a:ea typeface="맑은 고딕"/>
                           <a:cs typeface="맑은 고딕"/>
                         </a:rPr>
-                        <a:t>Q1 결정 경로 hop: 적음  ·  Q2 stale: 거의 없음</a:t>
+                        <a:t>Q1 압박 대응 지연: 최소 · 판단 중 갱신 경합  ·  Q2 stale: 거의 없음</a:t>
                       </a:r>
                     </a:p>
                     <a:p>
@@ -6221,7 +6221,7 @@
                           <a:ea typeface="맑은 고딕"/>
                           <a:cs typeface="맑은 고딕"/>
                         </a:rPr>
-                        <a:t>Q1 결정 hop +1이나 판단·갱신 경로 분리  ·  Q2 stale: snapshot age만큼</a:t>
+                        <a:t>Q1 갱신 경합 없음 · snapshot age만큼 대응 지연  ·  Q2 stale: snapshot age만큼</a:t>
                       </a:r>
                     </a:p>
                     <a:p>
@@ -12720,7 +12720,7 @@
                 <a:ea typeface="맑은 고딕"/>
                 <a:cs typeface="맑은 고딕"/>
               </a:rPr>
-              <a:t>Q. '결국 정책 차이 아닌가?'  A. 신호(자원 상태 / data 행동)는 정책 플러그인으로 두 안에 공통. 같은 정책(iso-policy)을 두 구조에 올려 결정 경로 hop, 수정 모듈 수, 지연 증가율로 비교</a:t>
+              <a:t>Q. '결국 정책 차이 아닌가?'  A. 신호(자원 상태 / data 행동)는 정책 플러그인으로 두 안에 공통. 같은 정책(iso-policy)을 두 구조에 올려 Max SLO Goodput과 분해 지표(HBM 확보 지연, 이동 거절율), 수정 모듈 수, 지연 증가율로 비교</a:t>
             </a:r>
           </a:p>
           <a:p>
@@ -14090,7 +14090,7 @@
                           <a:ea typeface="맑은 고딕"/>
                           <a:cs typeface="맑은 고딕"/>
                         </a:rPr>
-                        <a:t>결정 경로 hop 수와 event→Intent 지연 (μs), 판단 부하 시 commit→Registry 반영 지연 P99 (ms). 결정은 비동기라 forward 밖이므로 Goodput 차이는 작을 수 있음</a:t>
+                        <a:t>Max SLO Goodput의 분해: 압박→HBM 확보 완료 지연 (ms), 판단 중 상태 갱신 지연 P99 (ms), stale 판단의 이동 거절율 (%), TPOT P99 증분 (ms)</a:t>
                       </a:r>
                     </a:p>
                   </a:txBody>
@@ -14139,7 +14139,7 @@
                           <a:ea typeface="맑은 고딕"/>
                           <a:cs typeface="맑은 고딕"/>
                         </a:rPr>
-                        <a:t>조회가 로컬 호출, hop 0. 단 긴 판단 연산이 같은 서비스의 commit 반영·수집을 지연(head-of-line blocking)시킬 수 있음</a:t>
+                        <a:t>상태 항상 최신 → 압박 대응 지연 최소. 단 판단이 상태를 점유하는 동안 event 수집·commit 반영이 밀려 backlog 발생 가능</a:t>
                       </a:r>
                     </a:p>
                     <a:p>
@@ -14206,7 +14206,7 @@
                           <a:ea typeface="맑은 고딕"/>
                           <a:cs typeface="맑은 고딕"/>
                         </a:rPr>
-                        <a:t>snapshot query hop +1. 대신 판단 부하와 상태 갱신 경로가 분리되어 commit 반영 지연 없음, 판단 스레드의 서빙 코어 간섭 격리</a:t>
+                        <a:t>판단이 snapshot 위에서 돌아 갱신 경로와 경합 없음, 서빙 코어 간섭 격리. 단 snapshot age만큼 확보 지연, stale 판단 거절 증가, snapshot 생성 비용</a:t>
                       </a:r>
                     </a:p>
                     <a:p>
@@ -14273,7 +14273,7 @@
                           <a:ea typeface="맑은 고딕"/>
                           <a:cs typeface="맑은 고딕"/>
                         </a:rPr>
-                        <a:t>결정 비용 sweep (0.1 / 1 / 10 ms)</a:t>
+                        <a:t>snapshot age, 판단 비용(0.1 / 1 / 10 ms), 상태 갱신 rate sweep (iso-policy)</a:t>
                       </a:r>
                     </a:p>
                     <a:p>
@@ -17164,7 +17164,7 @@
                           <a:ea typeface="맑은 고딕"/>
                           <a:cs typeface="맑은 고딕"/>
                         </a:rPr>
-                        <a:t>Q1 처리량: 유지 (Lease 갱신이 판단 경로와 분리) [가설]</a:t>
+                        <a:t>Q1 처리량: 확인 필요 (만료 오판 → 재stage-in 비용, 연장 규칙이 관건) [가설]</a:t>
                       </a:r>
                     </a:p>
                     <a:p>

</xml_diff>